<commit_message>
Correct LAVAD sampling claim in deck, script and handbook (LAVAD samples every 16th frame too); add AnyAnomaly 80.7 on UCF-Crime; state metric sensitivity on UCF-Crime
</commit_message>
<xml_diff>
--- a/docs/06_presentations/DA-ZVAD_Phase3_Review.pptx
+++ b/docs/06_presentations/DA-ZVAD_Phase3_Review.pptx
@@ -1654,7 +1654,7 @@
           <a:lstStyle/>
           <a:p>
             <a:r>
-              <a:t>The strongest slide for credibility. The predictions were committed to git before any score existed. Say P1 failed before anyone asks, and that the claim was narrowed because of it. On LAVAD: 'comparable or better' - they score every frame, we score every 16th.</a:t>
+              <a:t>The strongest slide for credibility. The predictions were committed to git before any score existed. Say P1 failed before anyone asks, and that the claim was narrowed because of it. On LAVAD: 'comparable or better'. LAVAD samples every 16th frame too, but other papers' numbers can differ by small protocol details. AnyAnomaly gets 0.807 here - below us, unlike on the campus benchmarks.</a:t>
             </a:r>
           </a:p>
         </p:txBody>
@@ -16806,7 +16806,7 @@
                 </a:solidFill>
                 <a:latin typeface="Segoe UI"/>
               </a:rPr>
-              <a:t>AUROC, no training — LAVAD reports 0.803</a:t>
+              <a:t>AUROC, no training — LAVAD 0.803, AnyAnomaly 0.807</a:t>
             </a:r>
           </a:p>
         </p:txBody>
@@ -17767,7 +17767,7 @@
                 </a:solidFill>
                 <a:latin typeface="Segoe UI"/>
               </a:rPr>
-              <a:t>The video's own LLaVA sentence reaches 0.824; borrowed sentences average 0.713, below having none. The dashed line is LAVAD's 0.803 — it scores every frame and we score every 16th, so read it as comparable, not as a margin.</a:t>
+              <a:t>The video's own LLaVA sentence reaches 0.824; borrowed sentences average 0.713, below having none. The dashed line is LAVAD's 0.803 (AnyAnomaly: 0.807). Both are other papers' numbers, so read it as comparable, not as a margin.</a:t>
             </a:r>
           </a:p>
         </p:txBody>
@@ -20289,7 +20289,7 @@
                 </a:solidFill>
                 <a:latin typeface="Segoe UI"/>
               </a:rPr>
-              <a:t>Protocol differences.  </a:t>
+              <a:t>Metric sensitivity on UCF-Crime.  </a:t>
             </a:r>
             <a:r>
               <a:rPr sz="1450">
@@ -20298,7 +20298,7 @@
                 </a:solidFill>
                 <a:latin typeface="Segoe UI"/>
               </a:rPr>
-              <a:t>UCF-Crime is scored every 16th frame, LAVAD every frame; each video's sentence comes from its first second of footage.</a:t>
+              <a:t>Under per-video normalisation the context effect shrinks sharply; we report the pre-registered raw metric.</a:t>
             </a:r>
           </a:p>
         </p:txBody>
@@ -20962,7 +20962,7 @@
                           </a:solidFill>
                           <a:latin typeface="Segoe UI"/>
                         </a:rPr>
-                        <a:t>UCF-Crime scored at every frame</a:t>
+                        <a:t>UCF-Crime with scores propagated to every frame</a:t>
                       </a:r>
                     </a:p>
                   </a:txBody>
@@ -20985,7 +20985,7 @@
                           </a:solidFill>
                           <a:latin typeface="Segoe UI"/>
                         </a:rPr>
-                        <a:t>Removes the one protocol difference from LAVAD</a:t>
+                        <a:t>Comparable to LAVAD under either reading of its protocol</a:t>
                       </a:r>
                     </a:p>
                   </a:txBody>

</xml_diff>

<commit_message>
Phase 3 deck full audit: setup slide (3 benchmarks, 418 videos, LLaVA), UCF-Crime in comparison and scene-count tables, wrong Ada-VAD citation fixed, within-video finding on interpretation/limitations/summary, plan follows master plan, references regenerated
</commit_message>
<xml_diff>
--- a/docs/06_presentations/DA-ZVAD_Phase3_Review.pptx
+++ b/docs/06_presentations/DA-ZVAD_Phase3_Review.pptx
@@ -534,7 +534,7 @@
           <a:lstStyle/>
           <a:p>
             <a:r>
-              <a:t>Title. Introduce yourself and the one-line premise: adapting an anomaly detector to a new place by writing a sentence, with nothing retrained.</a:t>
+              <a:t>Title. Introduce yourself and the one-line premise: adapting an anomaly detector to a new camera with one sentence the system writes itself, with nothing retrained.</a:t>
             </a:r>
           </a:p>
         </p:txBody>
@@ -884,7 +884,7 @@
           <a:lstStyle/>
           <a:p>
             <a:r>
-              <a:t>The headline. Point at the none column being identical in both rows - that is the control, and it proves only the injection point changed. Then point at 0.628 and say a wrong sentence costs ten points.</a:t>
+              <a:t>The headline. Point at the none column being identical in both rows - that is the control, and it proves only the injection point changed. Then point at 0.628 and say a wrong sentence costs ten points on the benchmark metric. Do not say 'the text redefines normal' - slide 17 explains why.</a:t>
             </a:r>
           </a:p>
         </p:txBody>
@@ -1094,7 +1094,7 @@
           <a:lstStyle/>
           <a:p>
             <a:r>
-              <a:t>Be scrupulous. The +0.027 is positive at every window but sits inside the spread, so we report direction and not magnitude. The claim rests on the mismatched penalty. Understating here protects you.</a:t>
+              <a:t>Be scrupulous. The +0.027 sits inside the spread, so we report direction only. Then the Phase 3 check, said plainly: judged only inside each video, the gap is +0.006. The sentence mostly shifts each video's score level - it tells cameras apart - rather than re-ranking frames. We found this ourselves and the audit is the next experiment. Saying it first is what protects you.</a:t>
             </a:r>
           </a:p>
         </p:txBody>
@@ -1374,7 +1374,7 @@
           <a:lstStyle/>
           <a:p>
             <a:r>
-              <a:t>The most important slide in the deck. Detection transfers almost exactly; the adaptation does not. Give the honest reading - on Avenue a placeholder beats an accurate description, so that benefit cannot be domain adaptation. Then give the conjecture AND the experiment that would settle it.</a:t>
+              <a:t>The most important slide in the deck. Detection transfers almost exactly; the adaptation does not. Give the honest reading - on Avenue a placeholder beats an accurate description, so that benefit cannot be domain adaptation. Then give the conjecture AND the experiment that would settle it - the next slide, and UCF-Crime later in the deck.</a:t>
             </a:r>
           </a:p>
         </p:txBody>
@@ -1444,7 +1444,7 @@
           <a:lstStyle/>
           <a:p>
             <a:r>
-              <a:t>This is the slide that shows a full cycle: we saw something odd, formed an explanation, designed a test that could have killed it, ran it, and it held. Say out loud that a gap near +0.105 here would have refuted us. Then give the caveat yourself - three of nine views are negative, so within one scene the effect is not reliable.</a:t>
+              <a:t>This is the slide that shows a full cycle: we saw something odd, formed an explanation, designed a test that could have killed it, ran it, and it held. Say out loud that a gap near +0.105 here would have refuted us. Then give the caveat yourself - three of nine views are negative, so within one scene the effect is not reliable. The last row is Phase 3: ~290 scenes gave no bigger gap than 12, so the claim is 'needs scenes', not 'grows with scenes'.</a:t>
             </a:r>
           </a:p>
         </p:txBody>
@@ -1864,7 +1864,7 @@
           <a:lstStyle/>
           <a:p>
             <a:r>
-              <a:t>Anchor on the trained baseline: 73.4 matches the benchmark's own 2018 baseline using none of its training data. Then the reframe - AnyAnomaly is handed the class list, we are not. The LAVAD comparison lives on the UCF-Crime slide, not here.</a:t>
+              <a:t>Anchor on the trained baseline: 73.4 matches the benchmark's own 2018 baseline using none of its training data. Then the reframe - AnyAnomaly is handed the class list, we are not. Then the UCF column: first of six training-free methods, above LAVAD and AnyAnomaly - say 'comparable or better', since these are other papers' numbers. The ‡ rows come from LAVAD's paper, the rest from AnyAnomaly's.</a:t>
             </a:r>
           </a:p>
         </p:txBody>
@@ -1934,7 +1934,7 @@
           <a:lstStyle/>
           <a:p>
             <a:r>
-              <a:t>Deliver these confidently rather than apologetically. The metric limitation is worth dwelling on - it is a real methodological point about a protocol the whole field uses, and we found it by chasing our own bug.</a:t>
+              <a:t>Deliver these confidently rather than apologetically. Dwell on the first two: we found ourselves that the pooled metric rewards score shifts, and that applies to every CLIP-based zero-shot VAD paper, not only ours.</a:t>
             </a:r>
           </a:p>
         </p:txBody>
@@ -2004,7 +2004,7 @@
           <a:lstStyle/>
           <a:p>
             <a:r>
-              <a:t>XD-Violence first: it is LAVAD's other benchmark, so it completes that comparison. Patch-level scoring is the best shot at a higher number. Point at the box at the bottom - everything listed there was the Phase 2 plan, now done.</a:t>
+              <a:t>The audit comes first because it decides how the result is described. Then XD-Violence, LAVAD's other benchmark. NWPU Campus is the one dataset where the same event is normal in one scene and abnormal in another - the direct test of concept shift. Point at the box at the bottom for what is done.</a:t>
             </a:r>
           </a:p>
         </p:txBody>
@@ -2144,7 +2144,7 @@
           <a:lstStyle/>
           <a:p>
             <a:r>
-              <a:t>Close on the boundary, not the number. Say plainly that one registered prediction failed and the claim was narrowed because of it. Then hand over.</a:t>
+              <a:t>Close on the boundary, not the number. Say plainly that one registered prediction failed and the claim was narrowed, and that the within-video check is being audited. Then hand over.</a:t>
             </a:r>
           </a:p>
         </p:txBody>
@@ -2494,7 +2494,7 @@
           <a:lstStyle/>
           <a:p>
             <a:r>
-              <a:t>Walk the four modules left to right in about thirty seconds. Then stop on M3 - the orange box - and say that is the only place the domain enters.</a:t>
+              <a:t>Walk the four modules left to right in about thirty seconds. Point at the SETUP box: LLaVA captions a new camera's first frames and that caption is the camera's sentence - no human needed. Then stop on M3, the only place the domain enters, and its one rule: the sentence goes into the normal prompts only.</a:t>
             </a:r>
           </a:p>
         </p:txBody>
@@ -2564,7 +2564,7 @@
           <a:lstStyle/>
           <a:p>
             <a:r>
-              <a:t>The strongest methodological point in the deck. Say it slowly. And note that the competing systems CANNOT run our experiment - their text is learned on source data, or entangled in an LLM prior, or paired with a trained adapter.</a:t>
+              <a:t>The strongest methodological point in the deck. Say it slowly. And note that the competing systems CANNOT run our experiment - their text is learned on training data (VERA), or entangled in an LLM prior (LAVAD), or paired with trained detection heads (OVVAD).</a:t>
             </a:r>
           </a:p>
         </p:txBody>
@@ -2704,7 +2704,7 @@
           <a:lstStyle/>
           <a:p>
             <a:r>
-              <a:t>Keep this brief - it is the credibility slide. If anyone doubts the work is yours, offer to open a manifest. Five runs, all recorded.</a:t>
+              <a:t>Keep this brief - it is the credibility slide. If anyone doubts the work is yours, offer to open a manifest. Three video benchmarks now, UCF-Crime added in Phase 3; MVTec is only the image baseline.</a:t>
             </a:r>
           </a:p>
         </p:txBody>
@@ -2774,7 +2774,7 @@
           <a:lstStyle/>
           <a:p>
             <a:r>
-              <a:t>Thirty seconds, no more. Point down one column and say the scene never changes - only the event does. If someone asks later why context matters, come back to this slide.</a:t>
+              <a:t>Thirty seconds, no more. Point down one column and say the scene never changes - only the event does. Then one line on UCF-Crime: there, almost every video is a different place, which is why each gets its own sentence.</a:t>
             </a:r>
           </a:p>
         </p:txBody>
@@ -10141,7 +10141,7 @@
                 </a:solidFill>
                 <a:latin typeface="Segoe UI"/>
               </a:rPr>
-              <a:t>Nothing else in the system was permitted to change. The text caused it.</a:t>
+              <a:t>Nothing else was permitted to change, so the text caused it — slide 17 says how.</a:t>
             </a:r>
           </a:p>
         </p:txBody>
@@ -11435,8 +11435,8 @@
                 </a:solidFill>
                 <a:latin typeface="Segoe UI"/>
               </a:rPr>
-              <a:t>A WRONG description costs −0.105.
-Unambiguous, and nothing else could have caused it.</a:t>
+              <a:t>A WRONG description lowers the benchmark score by 0.105.
+Nothing else could have caused it.</a:t>
             </a:r>
           </a:p>
         </p:txBody>
@@ -11450,13 +11450,13 @@
         <p:spPr>
           <a:xfrm>
             <a:off x="777240" y="4023360"/>
-            <a:ext cx="10637215" cy="1280160"/>
+            <a:ext cx="10637215" cy="1417320"/>
           </a:xfrm>
           <a:prstGeom prst="rect">
             <a:avLst/>
           </a:prstGeom>
           <a:solidFill>
-            <a:srgbClr val="DDEDEB"/>
+            <a:srgbClr val="F6EBD8"/>
           </a:solidFill>
           <a:ln>
             <a:noFill/>
@@ -11494,13 +11494,13 @@
         <p:spPr>
           <a:xfrm>
             <a:off x="777240" y="4023360"/>
-            <a:ext cx="45720" cy="1280160"/>
+            <a:ext cx="45720" cy="1417320"/>
           </a:xfrm>
           <a:prstGeom prst="rect">
             <a:avLst/>
           </a:prstGeom>
           <a:solidFill>
-            <a:srgbClr val="0D6B67"/>
+            <a:srgbClr val="8A5715"/>
           </a:solidFill>
           <a:ln>
             <a:noFill/>
@@ -11559,11 +11559,11 @@
             <a:r>
               <a:rPr sz="1050" b="1" i="0">
                 <a:solidFill>
-                  <a:srgbClr val="0D6B67"/>
-                </a:solidFill>
-                <a:latin typeface="Segoe UI"/>
-              </a:rPr>
-              <a:t>HOW TO READ THE MECHANISM</a:t>
+                  <a:srgbClr val="8A5715"/>
+                </a:solidFill>
+                <a:latin typeface="Segoe UI"/>
+              </a:rPr>
+              <a:t>WHAT A SECOND METRIC SHOWED (PHASE 3)</a:t>
             </a:r>
           </a:p>
         </p:txBody>
@@ -11577,7 +11577,7 @@
         <p:spPr>
           <a:xfrm>
             <a:off x="1033271" y="4462272"/>
-            <a:ext cx="10134295" cy="713231"/>
+            <a:ext cx="10134295" cy="850392"/>
           </a:xfrm>
           <a:prstGeom prst="rect">
             <a:avLst/>
@@ -11596,13 +11596,13 @@
               </a:lnSpc>
             </a:pPr>
             <a:r>
-              <a:rPr sz="1600" b="0" i="0">
+              <a:rPr sz="1500" b="0" i="0">
                 <a:solidFill>
                   <a:srgbClr val="141C1E"/>
                 </a:solidFill>
                 <a:latin typeface="Segoe UI"/>
               </a:rPr>
-              <a:t>The description constrains a decision boundary rather than adding information. It does not reliably lift performance when correct; it degrades performance sharply when misdirected.</a:t>
+              <a:t>Judged only by which frames rank highest INSIDE each video, the gap is +0.006. The sentence mostly shifts each video's overall score level — telling cameras apart — and the pooled metric rewards that. It barely re-ranks frames within a video. A full audit is the next experiment.</a:t>
             </a:r>
           </a:p>
         </p:txBody>
@@ -14769,7 +14769,7 @@
                 </a:solidFill>
                 <a:latin typeface="Segoe UI"/>
               </a:rPr>
-              <a:t>ShanghaiTech has 12 camera views; Avenue has one. A scene description has work to do only when there are several environments to tell apart. Testable: run the sweep inside a single ShanghaiTech view.</a:t>
+              <a:t>ShanghaiTech has 12 camera views; Avenue has one, so a scene description has nothing to tell apart. Tested next inside single ShanghaiTech views, and later on UCF-Crime's ~290 scenes.</a:t>
             </a:r>
           </a:p>
         </p:txBody>
@@ -15045,8 +15045,8 @@
           <p:nvPr/>
         </p:nvGraphicFramePr>
         <p:xfrm>
-          <a:off x="777240" y="2606040"/>
-          <a:ext cx="10634472" cy="2048256"/>
+          <a:off x="777240" y="2468880"/>
+          <a:ext cx="10634472" cy="2148840"/>
         </p:xfrm>
         <a:graphic>
           <a:graphicData uri="http://schemas.openxmlformats.org/drawingml/2006/table">
@@ -15060,7 +15060,7 @@
                 <a:gridCol w="2103120"/>
                 <a:gridCol w="1673352"/>
               </a:tblGrid>
-              <a:tr h="512064">
+              <a:tr h="429768">
                 <a:tc>
                   <a:txBody>
                     <a:bodyPr wrap="square"/>
@@ -15068,7 +15068,7 @@
                     <a:p>
                       <a:pPr algn="l"/>
                       <a:r>
-                        <a:rPr sz="1500" b="1">
+                        <a:rPr sz="1400" b="1">
                           <a:solidFill>
                             <a:srgbClr val="FFFFFF"/>
                           </a:solidFill>
@@ -15091,13 +15091,13 @@
                     <a:p>
                       <a:pPr algn="l"/>
                       <a:r>
-                        <a:rPr sz="1500" b="1">
+                        <a:rPr sz="1400" b="1">
                           <a:solidFill>
                             <a:srgbClr val="FFFFFF"/>
                           </a:solidFill>
                           <a:latin typeface="Segoe UI"/>
                         </a:rPr>
-                        <a:t>Views</a:t>
+                        <a:t>Scenes</a:t>
                       </a:r>
                     </a:p>
                   </a:txBody>
@@ -15114,7 +15114,7 @@
                     <a:p>
                       <a:pPr algn="l"/>
                       <a:r>
-                        <a:rPr sz="1500" b="1">
+                        <a:rPr sz="1400" b="1">
                           <a:solidFill>
                             <a:srgbClr val="FFFFFF"/>
                           </a:solidFill>
@@ -15137,7 +15137,7 @@
                     <a:p>
                       <a:pPr algn="r"/>
                       <a:r>
-                        <a:rPr sz="1500" b="1">
+                        <a:rPr sz="1400" b="1">
                           <a:solidFill>
                             <a:srgbClr val="FFFFFF"/>
                           </a:solidFill>
@@ -15154,7 +15154,7 @@
                   </a:tcPr>
                 </a:tc>
               </a:tr>
-              <a:tr h="512064">
+              <a:tr h="429768">
                 <a:tc>
                   <a:txBody>
                     <a:bodyPr wrap="square"/>
@@ -15162,13 +15162,13 @@
                     <a:p>
                       <a:pPr algn="l"/>
                       <a:r>
-                        <a:rPr sz="1500" b="0">
+                        <a:rPr sz="1400" b="0">
                           <a:solidFill>
                             <a:srgbClr val="141C1E"/>
                           </a:solidFill>
                           <a:latin typeface="Segoe UI"/>
                         </a:rPr>
-                        <a:t>Pooled across views</a:t>
+                        <a:t>CUHK Avenue (single view)</a:t>
                       </a:r>
                     </a:p>
                   </a:txBody>
@@ -15185,7 +15185,195 @@
                     <a:p>
                       <a:pPr algn="l"/>
                       <a:r>
-                        <a:rPr sz="1500" b="0">
+                        <a:rPr sz="1400" b="0">
+                          <a:solidFill>
+                            <a:srgbClr val="141C1E"/>
+                          </a:solidFill>
+                          <a:latin typeface="Segoe UI"/>
+                        </a:rPr>
+                        <a:t>1</a:t>
+                      </a:r>
+                    </a:p>
+                  </a:txBody>
+                  <a:tcPr marL="128016" marR="128016" marT="45720" marB="45720" anchor="ctr">
+                    <a:solidFill>
+                      <a:srgbClr val="FFFFFF"/>
+                    </a:solidFill>
+                  </a:tcPr>
+                </a:tc>
+                <a:tc>
+                  <a:txBody>
+                    <a:bodyPr wrap="square"/>
+                    <a:lstStyle/>
+                    <a:p>
+                      <a:pPr algn="l"/>
+                      <a:r>
+                        <a:rPr sz="1400" b="0">
+                          <a:solidFill>
+                            <a:srgbClr val="141C1E"/>
+                          </a:solidFill>
+                          <a:latin typeface="Segoe UI"/>
+                        </a:rPr>
+                        <a:t>21</a:t>
+                      </a:r>
+                    </a:p>
+                  </a:txBody>
+                  <a:tcPr marL="128016" marR="128016" marT="45720" marB="45720" anchor="ctr">
+                    <a:solidFill>
+                      <a:srgbClr val="FFFFFF"/>
+                    </a:solidFill>
+                  </a:tcPr>
+                </a:tc>
+                <a:tc>
+                  <a:txBody>
+                    <a:bodyPr wrap="square"/>
+                    <a:lstStyle/>
+                    <a:p>
+                      <a:pPr algn="r"/>
+                      <a:r>
+                        <a:rPr sz="1400" b="0">
+                          <a:solidFill>
+                            <a:srgbClr val="141C1E"/>
+                          </a:solidFill>
+                          <a:latin typeface="Consolas"/>
+                        </a:rPr>
+                        <a:t>+0.020</a:t>
+                      </a:r>
+                    </a:p>
+                  </a:txBody>
+                  <a:tcPr marL="128016" marR="128016" marT="45720" marB="45720" anchor="ctr">
+                    <a:solidFill>
+                      <a:srgbClr val="FFFFFF"/>
+                    </a:solidFill>
+                  </a:tcPr>
+                </a:tc>
+              </a:tr>
+              <a:tr h="429768">
+                <a:tc>
+                  <a:txBody>
+                    <a:bodyPr wrap="square"/>
+                    <a:lstStyle/>
+                    <a:p>
+                      <a:pPr algn="l"/>
+                      <a:r>
+                        <a:rPr sz="1400" b="1">
+                          <a:solidFill>
+                            <a:srgbClr val="141C1E"/>
+                          </a:solidFill>
+                          <a:latin typeface="Segoe UI"/>
+                        </a:rPr>
+                        <a:t>ShanghaiTech, within a single view (mean)</a:t>
+                      </a:r>
+                    </a:p>
+                  </a:txBody>
+                  <a:tcPr marL="128016" marR="128016" marT="45720" marB="45720" anchor="ctr">
+                    <a:solidFill>
+                      <a:srgbClr val="DDEDEB"/>
+                    </a:solidFill>
+                  </a:tcPr>
+                </a:tc>
+                <a:tc>
+                  <a:txBody>
+                    <a:bodyPr wrap="square"/>
+                    <a:lstStyle/>
+                    <a:p>
+                      <a:pPr algn="l"/>
+                      <a:r>
+                        <a:rPr sz="1400" b="1">
+                          <a:solidFill>
+                            <a:srgbClr val="141C1E"/>
+                          </a:solidFill>
+                          <a:latin typeface="Segoe UI"/>
+                        </a:rPr>
+                        <a:t>1 each</a:t>
+                      </a:r>
+                    </a:p>
+                  </a:txBody>
+                  <a:tcPr marL="128016" marR="128016" marT="45720" marB="45720" anchor="ctr">
+                    <a:solidFill>
+                      <a:srgbClr val="DDEDEB"/>
+                    </a:solidFill>
+                  </a:tcPr>
+                </a:tc>
+                <a:tc>
+                  <a:txBody>
+                    <a:bodyPr wrap="square"/>
+                    <a:lstStyle/>
+                    <a:p>
+                      <a:pPr algn="l"/>
+                      <a:r>
+                        <a:rPr sz="1400" b="1">
+                          <a:solidFill>
+                            <a:srgbClr val="141C1E"/>
+                          </a:solidFill>
+                          <a:latin typeface="Segoe UI"/>
+                        </a:rPr>
+                        <a:t>5–34 each</a:t>
+                      </a:r>
+                    </a:p>
+                  </a:txBody>
+                  <a:tcPr marL="128016" marR="128016" marT="45720" marB="45720" anchor="ctr">
+                    <a:solidFill>
+                      <a:srgbClr val="DDEDEB"/>
+                    </a:solidFill>
+                  </a:tcPr>
+                </a:tc>
+                <a:tc>
+                  <a:txBody>
+                    <a:bodyPr wrap="square"/>
+                    <a:lstStyle/>
+                    <a:p>
+                      <a:pPr algn="r"/>
+                      <a:r>
+                        <a:rPr sz="1400" b="1">
+                          <a:solidFill>
+                            <a:srgbClr val="141C1E"/>
+                          </a:solidFill>
+                          <a:latin typeface="Consolas"/>
+                        </a:rPr>
+                        <a:t>+0.033</a:t>
+                      </a:r>
+                    </a:p>
+                  </a:txBody>
+                  <a:tcPr marL="128016" marR="128016" marT="45720" marB="45720" anchor="ctr">
+                    <a:solidFill>
+                      <a:srgbClr val="DDEDEB"/>
+                    </a:solidFill>
+                  </a:tcPr>
+                </a:tc>
+              </a:tr>
+              <a:tr h="429768">
+                <a:tc>
+                  <a:txBody>
+                    <a:bodyPr wrap="square"/>
+                    <a:lstStyle/>
+                    <a:p>
+                      <a:pPr algn="l"/>
+                      <a:r>
+                        <a:rPr sz="1400" b="0">
+                          <a:solidFill>
+                            <a:srgbClr val="141C1E"/>
+                          </a:solidFill>
+                          <a:latin typeface="Segoe UI"/>
+                        </a:rPr>
+                        <a:t>ShanghaiTech, pooled across views</a:t>
+                      </a:r>
+                    </a:p>
+                  </a:txBody>
+                  <a:tcPr marL="128016" marR="128016" marT="45720" marB="45720" anchor="ctr">
+                    <a:solidFill>
+                      <a:srgbClr val="FFFFFF"/>
+                    </a:solidFill>
+                  </a:tcPr>
+                </a:tc>
+                <a:tc>
+                  <a:txBody>
+                    <a:bodyPr wrap="square"/>
+                    <a:lstStyle/>
+                    <a:p>
+                      <a:pPr algn="l"/>
+                      <a:r>
+                        <a:rPr sz="1400" b="0">
                           <a:solidFill>
                             <a:srgbClr val="141C1E"/>
                           </a:solidFill>
@@ -15208,7 +15396,7 @@
                     <a:p>
                       <a:pPr algn="l"/>
                       <a:r>
-                        <a:rPr sz="1500" b="0">
+                        <a:rPr sz="1400" b="0">
                           <a:solidFill>
                             <a:srgbClr val="141C1E"/>
                           </a:solidFill>
@@ -15231,7 +15419,7 @@
                     <a:p>
                       <a:pPr algn="r"/>
                       <a:r>
-                        <a:rPr sz="1500" b="0">
+                        <a:rPr sz="1400" b="0">
                           <a:solidFill>
                             <a:srgbClr val="141C1E"/>
                           </a:solidFill>
@@ -15248,7 +15436,7 @@
                   </a:tcPr>
                 </a:tc>
               </a:tr>
-              <a:tr h="512064">
+              <a:tr h="429768">
                 <a:tc>
                   <a:txBody>
                     <a:bodyPr wrap="square"/>
@@ -15256,19 +15444,19 @@
                     <a:p>
                       <a:pPr algn="l"/>
                       <a:r>
-                        <a:rPr sz="1500" b="1">
+                        <a:rPr sz="1400" b="0">
                           <a:solidFill>
                             <a:srgbClr val="141C1E"/>
                           </a:solidFill>
                           <a:latin typeface="Segoe UI"/>
                         </a:rPr>
-                        <a:t>Within a single view (mean)</a:t>
+                        <a:t>UCF-Crime, own sentence per video (Phase 3)</a:t>
                       </a:r>
                     </a:p>
                   </a:txBody>
                   <a:tcPr marL="128016" marR="128016" marT="45720" marB="45720" anchor="ctr">
                     <a:solidFill>
-                      <a:srgbClr val="DDEDEB"/>
+                      <a:srgbClr val="F5F7F7"/>
                     </a:solidFill>
                   </a:tcPr>
                 </a:tc>
@@ -15279,19 +15467,19 @@
                     <a:p>
                       <a:pPr algn="l"/>
                       <a:r>
-                        <a:rPr sz="1500" b="1">
+                        <a:rPr sz="1400" b="0">
                           <a:solidFill>
                             <a:srgbClr val="141C1E"/>
                           </a:solidFill>
                           <a:latin typeface="Segoe UI"/>
                         </a:rPr>
-                        <a:t>9</a:t>
+                        <a:t>~290</a:t>
                       </a:r>
                     </a:p>
                   </a:txBody>
                   <a:tcPr marL="128016" marR="128016" marT="45720" marB="45720" anchor="ctr">
                     <a:solidFill>
-                      <a:srgbClr val="DDEDEB"/>
+                      <a:srgbClr val="F5F7F7"/>
                     </a:solidFill>
                   </a:tcPr>
                 </a:tc>
@@ -15302,19 +15490,19 @@
                     <a:p>
                       <a:pPr algn="l"/>
                       <a:r>
-                        <a:rPr sz="1500" b="1">
+                        <a:rPr sz="1400" b="0">
                           <a:solidFill>
                             <a:srgbClr val="141C1E"/>
                           </a:solidFill>
                           <a:latin typeface="Segoe UI"/>
                         </a:rPr>
-                        <a:t>5–34 each</a:t>
+                        <a:t>290</a:t>
                       </a:r>
                     </a:p>
                   </a:txBody>
                   <a:tcPr marL="128016" marR="128016" marT="45720" marB="45720" anchor="ctr">
                     <a:solidFill>
-                      <a:srgbClr val="DDEDEB"/>
+                      <a:srgbClr val="F5F7F7"/>
                     </a:solidFill>
                   </a:tcPr>
                 </a:tc>
@@ -15325,113 +15513,19 @@
                     <a:p>
                       <a:pPr algn="r"/>
                       <a:r>
-                        <a:rPr sz="1500" b="1">
+                        <a:rPr sz="1400" b="0">
                           <a:solidFill>
                             <a:srgbClr val="141C1E"/>
                           </a:solidFill>
                           <a:latin typeface="Consolas"/>
                         </a:rPr>
-                        <a:t>+0.033</a:t>
+                        <a:t>+0.096</a:t>
                       </a:r>
                     </a:p>
                   </a:txBody>
                   <a:tcPr marL="128016" marR="128016" marT="45720" marB="45720" anchor="ctr">
                     <a:solidFill>
-                      <a:srgbClr val="DDEDEB"/>
-                    </a:solidFill>
-                  </a:tcPr>
-                </a:tc>
-              </a:tr>
-              <a:tr h="512064">
-                <a:tc>
-                  <a:txBody>
-                    <a:bodyPr wrap="square"/>
-                    <a:lstStyle/>
-                    <a:p>
-                      <a:pPr algn="l"/>
-                      <a:r>
-                        <a:rPr sz="1500" b="0">
-                          <a:solidFill>
-                            <a:srgbClr val="141C1E"/>
-                          </a:solidFill>
-                          <a:latin typeface="Segoe UI"/>
-                        </a:rPr>
-                        <a:t>CUHK Avenue (single view)</a:t>
-                      </a:r>
-                    </a:p>
-                  </a:txBody>
-                  <a:tcPr marL="128016" marR="128016" marT="45720" marB="45720" anchor="ctr">
-                    <a:solidFill>
-                      <a:srgbClr val="FFFFFF"/>
-                    </a:solidFill>
-                  </a:tcPr>
-                </a:tc>
-                <a:tc>
-                  <a:txBody>
-                    <a:bodyPr wrap="square"/>
-                    <a:lstStyle/>
-                    <a:p>
-                      <a:pPr algn="l"/>
-                      <a:r>
-                        <a:rPr sz="1500" b="0">
-                          <a:solidFill>
-                            <a:srgbClr val="141C1E"/>
-                          </a:solidFill>
-                          <a:latin typeface="Segoe UI"/>
-                        </a:rPr>
-                        <a:t>1</a:t>
-                      </a:r>
-                    </a:p>
-                  </a:txBody>
-                  <a:tcPr marL="128016" marR="128016" marT="45720" marB="45720" anchor="ctr">
-                    <a:solidFill>
-                      <a:srgbClr val="FFFFFF"/>
-                    </a:solidFill>
-                  </a:tcPr>
-                </a:tc>
-                <a:tc>
-                  <a:txBody>
-                    <a:bodyPr wrap="square"/>
-                    <a:lstStyle/>
-                    <a:p>
-                      <a:pPr algn="l"/>
-                      <a:r>
-                        <a:rPr sz="1500" b="0">
-                          <a:solidFill>
-                            <a:srgbClr val="141C1E"/>
-                          </a:solidFill>
-                          <a:latin typeface="Segoe UI"/>
-                        </a:rPr>
-                        <a:t>21</a:t>
-                      </a:r>
-                    </a:p>
-                  </a:txBody>
-                  <a:tcPr marL="128016" marR="128016" marT="45720" marB="45720" anchor="ctr">
-                    <a:solidFill>
-                      <a:srgbClr val="FFFFFF"/>
-                    </a:solidFill>
-                  </a:tcPr>
-                </a:tc>
-                <a:tc>
-                  <a:txBody>
-                    <a:bodyPr wrap="square"/>
-                    <a:lstStyle/>
-                    <a:p>
-                      <a:pPr algn="r"/>
-                      <a:r>
-                        <a:rPr sz="1500" b="0">
-                          <a:solidFill>
-                            <a:srgbClr val="141C1E"/>
-                          </a:solidFill>
-                          <a:latin typeface="Consolas"/>
-                        </a:rPr>
-                        <a:t>+0.020</a:t>
-                      </a:r>
-                    </a:p>
-                  </a:txBody>
-                  <a:tcPr marL="128016" marR="128016" marT="45720" marB="45720" anchor="ctr">
-                    <a:solidFill>
-                      <a:srgbClr val="FFFFFF"/>
+                      <a:srgbClr val="F5F7F7"/>
                     </a:solidFill>
                   </a:tcPr>
                 </a:tc>
@@ -15448,8 +15542,8 @@
         </p:nvSpPr>
         <p:spPr>
           <a:xfrm>
-            <a:off x="777240" y="4480560"/>
-            <a:ext cx="10637215" cy="1051560"/>
+            <a:off x="777240" y="4800600"/>
+            <a:ext cx="10637215" cy="960120"/>
           </a:xfrm>
           <a:prstGeom prst="rect">
             <a:avLst/>
@@ -15492,8 +15586,8 @@
         </p:nvSpPr>
         <p:spPr>
           <a:xfrm>
-            <a:off x="777240" y="4480560"/>
-            <a:ext cx="45720" cy="1051560"/>
+            <a:off x="777240" y="4800600"/>
+            <a:ext cx="45720" cy="960120"/>
           </a:xfrm>
           <a:prstGeom prst="rect">
             <a:avLst/>
@@ -15536,7 +15630,7 @@
         </p:nvSpPr>
         <p:spPr>
           <a:xfrm>
-            <a:off x="1033271" y="4626864"/>
+            <a:off x="1033271" y="4946904"/>
             <a:ext cx="10134295" cy="219456"/>
           </a:xfrm>
           <a:prstGeom prst="rect">
@@ -15575,8 +15669,8 @@
         </p:nvSpPr>
         <p:spPr>
           <a:xfrm>
-            <a:off x="1033271" y="4919472"/>
-            <a:ext cx="10134295" cy="484631"/>
+            <a:off x="1033271" y="5239512"/>
+            <a:ext cx="10134295" cy="393192"/>
           </a:xfrm>
           <a:prstGeom prst="rect">
             <a:avLst/>
@@ -15595,13 +15689,13 @@
               </a:lnSpc>
             </a:pPr>
             <a:r>
-              <a:rPr sz="1550" b="0" i="0">
+              <a:rPr sz="1400" b="0" i="0">
                 <a:solidFill>
                   <a:srgbClr val="141C1E"/>
                 </a:solidFill>
                 <a:latin typeface="Segoe UI"/>
               </a:rPr>
-              <a:t>A within-view gap near +0.105 would have refuted the explanation outright. It came back at a third of that, next to Avenue's figure.</a:t>
+              <a:t>A within-view gap near +0.105 would have refuted it; it came back at a third. But ~290 scenes gave no bigger gap than 12: it needs scenes, it does not keep growing.</a:t>
             </a:r>
           </a:p>
         </p:txBody>
@@ -15614,7 +15708,7 @@
         </p:nvSpPr>
         <p:spPr>
           <a:xfrm>
-            <a:off x="777240" y="5715000"/>
+            <a:off x="777240" y="5897880"/>
             <a:ext cx="10637215" cy="640080"/>
           </a:xfrm>
           <a:prstGeom prst="rect">
@@ -18756,7 +18850,7 @@
         </p:nvGraphicFramePr>
         <p:xfrm>
           <a:off x="777240" y="1755648"/>
-          <a:ext cx="10634472" cy="2816352"/>
+          <a:ext cx="10634472" cy="2779776"/>
         </p:xfrm>
         <a:graphic>
           <a:graphicData uri="http://schemas.openxmlformats.org/drawingml/2006/table">
@@ -18765,11 +18859,12 @@
                 <a:tableStyleId>{5C22544A-7EE6-4342-B048-85BDC9FD1C3A}</a:tableStyleId>
               </a:tblPr>
               <a:tblGrid>
-                <a:gridCol w="6766560"/>
-                <a:gridCol w="1920240"/>
-                <a:gridCol w="1947672"/>
+                <a:gridCol w="6035040"/>
+                <a:gridCol w="1463040"/>
+                <a:gridCol w="1463040"/>
+                <a:gridCol w="1673352"/>
               </a:tblGrid>
-              <a:tr h="402336">
+              <a:tr h="347472">
                 <a:tc>
                   <a:txBody>
                     <a:bodyPr wrap="square"/>
@@ -18777,7 +18872,7 @@
                     <a:p>
                       <a:pPr algn="l"/>
                       <a:r>
-                        <a:rPr sz="1400" b="1">
+                        <a:rPr sz="1350" b="1">
                           <a:solidFill>
                             <a:srgbClr val="FFFFFF"/>
                           </a:solidFill>
@@ -18800,7 +18895,7 @@
                     <a:p>
                       <a:pPr algn="l"/>
                       <a:r>
-                        <a:rPr sz="1400" b="1">
+                        <a:rPr sz="1350" b="1">
                           <a:solidFill>
                             <a:srgbClr val="FFFFFF"/>
                           </a:solidFill>
@@ -18823,7 +18918,7 @@
                     <a:p>
                       <a:pPr algn="l"/>
                       <a:r>
-                        <a:rPr sz="1400" b="1">
+                        <a:rPr sz="1350" b="1">
                           <a:solidFill>
                             <a:srgbClr val="FFFFFF"/>
                           </a:solidFill>
@@ -18839,8 +18934,6 @@
                     </a:solidFill>
                   </a:tcPr>
                 </a:tc>
-              </a:tr>
-              <a:tr h="402336">
                 <a:tc>
                   <a:txBody>
                     <a:bodyPr wrap="square"/>
@@ -18848,13 +18941,38 @@
                     <a:p>
                       <a:pPr algn="l"/>
                       <a:r>
-                        <a:rPr sz="1400" b="0">
+                        <a:rPr sz="1350" b="1">
+                          <a:solidFill>
+                            <a:srgbClr val="FFFFFF"/>
+                          </a:solidFill>
+                          <a:latin typeface="Segoe UI"/>
+                        </a:rPr>
+                        <a:t>UCF</a:t>
+                      </a:r>
+                    </a:p>
+                  </a:txBody>
+                  <a:tcPr marL="128016" marR="128016" marT="45720" marB="45720" anchor="ctr">
+                    <a:solidFill>
+                      <a:srgbClr val="141C1E"/>
+                    </a:solidFill>
+                  </a:tcPr>
+                </a:tc>
+              </a:tr>
+              <a:tr h="347472">
+                <a:tc>
+                  <a:txBody>
+                    <a:bodyPr wrap="square"/>
+                    <a:lstStyle/>
+                    <a:p>
+                      <a:pPr algn="l"/>
+                      <a:r>
+                        <a:rPr sz="1350" b="0">
                           <a:solidFill>
                             <a:srgbClr val="141C1E"/>
                           </a:solidFill>
                           <a:latin typeface="Segoe UI"/>
                         </a:rPr>
-                        <a:t>Zero-shot CLIP [2]</a:t>
+                        <a:t>Zero-shot CLIP [4]</a:t>
                       </a:r>
                     </a:p>
                   </a:txBody>
@@ -18871,7 +18989,7 @@
                     <a:p>
                       <a:pPr algn="l"/>
                       <a:r>
-                        <a:rPr sz="1400" b="0">
+                        <a:rPr sz="1350" b="0">
                           <a:solidFill>
                             <a:srgbClr val="141C1E"/>
                           </a:solidFill>
@@ -18894,7 +19012,7 @@
                     <a:p>
                       <a:pPr algn="l"/>
                       <a:r>
-                        <a:rPr sz="1400" b="0">
+                        <a:rPr sz="1350" b="0">
                           <a:solidFill>
                             <a:srgbClr val="141C1E"/>
                           </a:solidFill>
@@ -18910,8 +19028,6 @@
                     </a:solidFill>
                   </a:tcPr>
                 </a:tc>
-              </a:tr>
-              <a:tr h="402336">
                 <a:tc>
                   <a:txBody>
                     <a:bodyPr wrap="square"/>
@@ -18919,7 +19035,32 @@
                     <a:p>
                       <a:pPr algn="l"/>
                       <a:r>
-                        <a:rPr sz="1400" b="0">
+                        <a:rPr sz="1350" b="0">
+                          <a:solidFill>
+                            <a:srgbClr val="141C1E"/>
+                          </a:solidFill>
+                          <a:latin typeface="Segoe UI"/>
+                        </a:rPr>
+                        <a:t>53.2‡</a:t>
+                      </a:r>
+                    </a:p>
+                  </a:txBody>
+                  <a:tcPr marL="128016" marR="128016" marT="45720" marB="45720" anchor="ctr">
+                    <a:solidFill>
+                      <a:srgbClr val="FFFFFF"/>
+                    </a:solidFill>
+                  </a:tcPr>
+                </a:tc>
+              </a:tr>
+              <a:tr h="347472">
+                <a:tc>
+                  <a:txBody>
+                    <a:bodyPr wrap="square"/>
+                    <a:lstStyle/>
+                    <a:p>
+                      <a:pPr algn="l"/>
+                      <a:r>
+                        <a:rPr sz="1350" b="0">
                           <a:solidFill>
                             <a:srgbClr val="141C1E"/>
                           </a:solidFill>
@@ -18942,7 +19083,7 @@
                     <a:p>
                       <a:pPr algn="l"/>
                       <a:r>
-                        <a:rPr sz="1400" b="0">
+                        <a:rPr sz="1350" b="0">
                           <a:solidFill>
                             <a:srgbClr val="141C1E"/>
                           </a:solidFill>
@@ -18965,7 +19106,7 @@
                     <a:p>
                       <a:pPr algn="l"/>
                       <a:r>
-                        <a:rPr sz="1400" b="0">
+                        <a:rPr sz="1350" b="0">
                           <a:solidFill>
                             <a:srgbClr val="141C1E"/>
                           </a:solidFill>
@@ -18981,8 +19122,6 @@
                     </a:solidFill>
                   </a:tcPr>
                 </a:tc>
-              </a:tr>
-              <a:tr h="402336">
                 <a:tc>
                   <a:txBody>
                     <a:bodyPr wrap="square"/>
@@ -18990,7 +19129,32 @@
                     <a:p>
                       <a:pPr algn="l"/>
                       <a:r>
-                        <a:rPr sz="1400" b="0">
+                        <a:rPr sz="1350" b="0">
+                          <a:solidFill>
+                            <a:srgbClr val="141C1E"/>
+                          </a:solidFill>
+                          <a:latin typeface="Segoe UI"/>
+                        </a:rPr>
+                        <a:t>53.7‡</a:t>
+                      </a:r>
+                    </a:p>
+                  </a:txBody>
+                  <a:tcPr marL="128016" marR="128016" marT="45720" marB="45720" anchor="ctr">
+                    <a:solidFill>
+                      <a:srgbClr val="F5F7F7"/>
+                    </a:solidFill>
+                  </a:tcPr>
+                </a:tc>
+              </a:tr>
+              <a:tr h="347472">
+                <a:tc>
+                  <a:txBody>
+                    <a:bodyPr wrap="square"/>
+                    <a:lstStyle/>
+                    <a:p>
+                      <a:pPr algn="l"/>
+                      <a:r>
+                        <a:rPr sz="1350" b="0">
                           <a:solidFill>
                             <a:srgbClr val="141C1E"/>
                           </a:solidFill>
@@ -19013,7 +19177,7 @@
                     <a:p>
                       <a:pPr algn="l"/>
                       <a:r>
-                        <a:rPr sz="1400" b="0">
+                        <a:rPr sz="1350" b="0">
                           <a:solidFill>
                             <a:srgbClr val="141C1E"/>
                           </a:solidFill>
@@ -19036,7 +19200,7 @@
                     <a:p>
                       <a:pPr algn="l"/>
                       <a:r>
-                        <a:rPr sz="1400" b="0">
+                        <a:rPr sz="1350" b="0">
                           <a:solidFill>
                             <a:srgbClr val="141C1E"/>
                           </a:solidFill>
@@ -19052,8 +19216,6 @@
                     </a:solidFill>
                   </a:tcPr>
                 </a:tc>
-              </a:tr>
-              <a:tr h="402336">
                 <a:tc>
                   <a:txBody>
                     <a:bodyPr wrap="square"/>
@@ -19061,7 +19223,32 @@
                     <a:p>
                       <a:pPr algn="l"/>
                       <a:r>
-                        <a:rPr sz="1400" b="0">
+                        <a:rPr sz="1350" b="0">
+                          <a:solidFill>
+                            <a:srgbClr val="141C1E"/>
+                          </a:solidFill>
+                          <a:latin typeface="Segoe UI"/>
+                        </a:rPr>
+                        <a:t>72.8‡</a:t>
+                      </a:r>
+                    </a:p>
+                  </a:txBody>
+                  <a:tcPr marL="128016" marR="128016" marT="45720" marB="45720" anchor="ctr">
+                    <a:solidFill>
+                      <a:srgbClr val="FFFFFF"/>
+                    </a:solidFill>
+                  </a:tcPr>
+                </a:tc>
+              </a:tr>
+              <a:tr h="347472">
+                <a:tc>
+                  <a:txBody>
+                    <a:bodyPr wrap="square"/>
+                    <a:lstStyle/>
+                    <a:p>
+                      <a:pPr algn="l"/>
+                      <a:r>
+                        <a:rPr sz="1350" b="0">
                           <a:solidFill>
                             <a:srgbClr val="141C1E"/>
                           </a:solidFill>
@@ -19084,7 +19271,7 @@
                     <a:p>
                       <a:pPr algn="l"/>
                       <a:r>
-                        <a:rPr sz="1400" b="0">
+                        <a:rPr sz="1350" b="0">
                           <a:solidFill>
                             <a:srgbClr val="141C1E"/>
                           </a:solidFill>
@@ -19107,7 +19294,7 @@
                     <a:p>
                       <a:pPr algn="l"/>
                       <a:r>
-                        <a:rPr sz="1400" b="0">
+                        <a:rPr sz="1350" b="0">
                           <a:solidFill>
                             <a:srgbClr val="141C1E"/>
                           </a:solidFill>
@@ -19123,8 +19310,6 @@
                     </a:solidFill>
                   </a:tcPr>
                 </a:tc>
-              </a:tr>
-              <a:tr h="402336">
                 <a:tc>
                   <a:txBody>
                     <a:bodyPr wrap="square"/>
@@ -19132,13 +19317,38 @@
                     <a:p>
                       <a:pPr algn="l"/>
                       <a:r>
-                        <a:rPr sz="1400" b="0">
+                        <a:rPr sz="1350" b="0">
                           <a:solidFill>
                             <a:srgbClr val="141C1E"/>
                           </a:solidFill>
                           <a:latin typeface="Segoe UI"/>
                         </a:rPr>
-                        <a:t>DA-ZVAD (ours) — one frozen encoder + a sentence</a:t>
+                        <a:t>—</a:t>
+                      </a:r>
+                    </a:p>
+                  </a:txBody>
+                  <a:tcPr marL="128016" marR="128016" marT="45720" marB="45720" anchor="ctr">
+                    <a:solidFill>
+                      <a:srgbClr val="F5F7F7"/>
+                    </a:solidFill>
+                  </a:tcPr>
+                </a:tc>
+              </a:tr>
+              <a:tr h="347472">
+                <a:tc>
+                  <a:txBody>
+                    <a:bodyPr wrap="square"/>
+                    <a:lstStyle/>
+                    <a:p>
+                      <a:pPr algn="l"/>
+                      <a:r>
+                        <a:rPr sz="1350" b="0">
+                          <a:solidFill>
+                            <a:srgbClr val="141C1E"/>
+                          </a:solidFill>
+                          <a:latin typeface="Segoe UI"/>
+                        </a:rPr>
+                        <a:t>LAVAD [3] — captioner + LLM + refiner</a:t>
                       </a:r>
                     </a:p>
                   </a:txBody>
@@ -19155,13 +19365,13 @@
                     <a:p>
                       <a:pPr algn="l"/>
                       <a:r>
-                        <a:rPr sz="1400" b="0">
+                        <a:rPr sz="1350" b="0">
                           <a:solidFill>
                             <a:srgbClr val="141C1E"/>
                           </a:solidFill>
                           <a:latin typeface="Segoe UI"/>
                         </a:rPr>
-                        <a:t>67.7</a:t>
+                        <a:t>—</a:t>
                       </a:r>
                     </a:p>
                   </a:txBody>
@@ -19178,13 +19388,36 @@
                     <a:p>
                       <a:pPr algn="l"/>
                       <a:r>
-                        <a:rPr sz="1400" b="0">
+                        <a:rPr sz="1350" b="0">
                           <a:solidFill>
                             <a:srgbClr val="141C1E"/>
                           </a:solidFill>
                           <a:latin typeface="Segoe UI"/>
                         </a:rPr>
-                        <a:t>73.4</a:t>
+                        <a:t>—</a:t>
+                      </a:r>
+                    </a:p>
+                  </a:txBody>
+                  <a:tcPr marL="128016" marR="128016" marT="45720" marB="45720" anchor="ctr">
+                    <a:solidFill>
+                      <a:srgbClr val="FFFFFF"/>
+                    </a:solidFill>
+                  </a:tcPr>
+                </a:tc>
+                <a:tc>
+                  <a:txBody>
+                    <a:bodyPr wrap="square"/>
+                    <a:lstStyle/>
+                    <a:p>
+                      <a:pPr algn="l"/>
+                      <a:r>
+                        <a:rPr sz="1350" b="0">
+                          <a:solidFill>
+                            <a:srgbClr val="141C1E"/>
+                          </a:solidFill>
+                          <a:latin typeface="Segoe UI"/>
+                        </a:rPr>
+                        <a:t>80.3‡</a:t>
                       </a:r>
                     </a:p>
                   </a:txBody>
@@ -19195,7 +19428,7 @@
                   </a:tcPr>
                 </a:tc>
               </a:tr>
-              <a:tr h="402336">
+              <a:tr h="347472">
                 <a:tc>
                   <a:txBody>
                     <a:bodyPr wrap="square"/>
@@ -19203,13 +19436,13 @@
                     <a:p>
                       <a:pPr algn="l"/>
                       <a:r>
-                        <a:rPr sz="1400" b="1">
+                        <a:rPr sz="1350" b="1">
                           <a:solidFill>
                             <a:srgbClr val="141C1E"/>
                           </a:solidFill>
                           <a:latin typeface="Segoe UI"/>
                         </a:rPr>
-                        <a:t>AnyAnomaly [9] — 3 LVLM queries per segment</a:t>
+                        <a:t>DA-ZVAD (ours) — one frozen encoder + a sentence</a:t>
                       </a:r>
                     </a:p>
                   </a:txBody>
@@ -19226,13 +19459,13 @@
                     <a:p>
                       <a:pPr algn="l"/>
                       <a:r>
-                        <a:rPr sz="1400" b="1">
+                        <a:rPr sz="1350" b="1">
                           <a:solidFill>
                             <a:srgbClr val="141C1E"/>
                           </a:solidFill>
                           <a:latin typeface="Segoe UI"/>
                         </a:rPr>
-                        <a:t>87.3</a:t>
+                        <a:t>67.7</a:t>
                       </a:r>
                     </a:p>
                   </a:txBody>
@@ -19249,7 +19482,101 @@
                     <a:p>
                       <a:pPr algn="l"/>
                       <a:r>
-                        <a:rPr sz="1400" b="1">
+                        <a:rPr sz="1350" b="1">
+                          <a:solidFill>
+                            <a:srgbClr val="141C1E"/>
+                          </a:solidFill>
+                          <a:latin typeface="Segoe UI"/>
+                        </a:rPr>
+                        <a:t>73.4</a:t>
+                      </a:r>
+                    </a:p>
+                  </a:txBody>
+                  <a:tcPr marL="128016" marR="128016" marT="45720" marB="45720" anchor="ctr">
+                    <a:solidFill>
+                      <a:srgbClr val="DDEDEB"/>
+                    </a:solidFill>
+                  </a:tcPr>
+                </a:tc>
+                <a:tc>
+                  <a:txBody>
+                    <a:bodyPr wrap="square"/>
+                    <a:lstStyle/>
+                    <a:p>
+                      <a:pPr algn="l"/>
+                      <a:r>
+                        <a:rPr sz="1350" b="1">
+                          <a:solidFill>
+                            <a:srgbClr val="141C1E"/>
+                          </a:solidFill>
+                          <a:latin typeface="Segoe UI"/>
+                        </a:rPr>
+                        <a:t>82.4</a:t>
+                      </a:r>
+                    </a:p>
+                  </a:txBody>
+                  <a:tcPr marL="128016" marR="128016" marT="45720" marB="45720" anchor="ctr">
+                    <a:solidFill>
+                      <a:srgbClr val="DDEDEB"/>
+                    </a:solidFill>
+                  </a:tcPr>
+                </a:tc>
+              </a:tr>
+              <a:tr h="347472">
+                <a:tc>
+                  <a:txBody>
+                    <a:bodyPr wrap="square"/>
+                    <a:lstStyle/>
+                    <a:p>
+                      <a:pPr algn="l"/>
+                      <a:r>
+                        <a:rPr sz="1350" b="0">
+                          <a:solidFill>
+                            <a:srgbClr val="141C1E"/>
+                          </a:solidFill>
+                          <a:latin typeface="Segoe UI"/>
+                        </a:rPr>
+                        <a:t>AnyAnomaly [2] — 3 LVLM queries per segment</a:t>
+                      </a:r>
+                    </a:p>
+                  </a:txBody>
+                  <a:tcPr marL="128016" marR="128016" marT="45720" marB="45720" anchor="ctr">
+                    <a:solidFill>
+                      <a:srgbClr val="FFFFFF"/>
+                    </a:solidFill>
+                  </a:tcPr>
+                </a:tc>
+                <a:tc>
+                  <a:txBody>
+                    <a:bodyPr wrap="square"/>
+                    <a:lstStyle/>
+                    <a:p>
+                      <a:pPr algn="l"/>
+                      <a:r>
+                        <a:rPr sz="1350" b="0">
+                          <a:solidFill>
+                            <a:srgbClr val="141C1E"/>
+                          </a:solidFill>
+                          <a:latin typeface="Segoe UI"/>
+                        </a:rPr>
+                        <a:t>87.3</a:t>
+                      </a:r>
+                    </a:p>
+                  </a:txBody>
+                  <a:tcPr marL="128016" marR="128016" marT="45720" marB="45720" anchor="ctr">
+                    <a:solidFill>
+                      <a:srgbClr val="FFFFFF"/>
+                    </a:solidFill>
+                  </a:tcPr>
+                </a:tc>
+                <a:tc>
+                  <a:txBody>
+                    <a:bodyPr wrap="square"/>
+                    <a:lstStyle/>
+                    <a:p>
+                      <a:pPr algn="l"/>
+                      <a:r>
+                        <a:rPr sz="1350" b="0">
                           <a:solidFill>
                             <a:srgbClr val="141C1E"/>
                           </a:solidFill>
@@ -19261,7 +19588,30 @@
                   </a:txBody>
                   <a:tcPr marL="128016" marR="128016" marT="45720" marB="45720" anchor="ctr">
                     <a:solidFill>
-                      <a:srgbClr val="DDEDEB"/>
+                      <a:srgbClr val="FFFFFF"/>
+                    </a:solidFill>
+                  </a:tcPr>
+                </a:tc>
+                <a:tc>
+                  <a:txBody>
+                    <a:bodyPr wrap="square"/>
+                    <a:lstStyle/>
+                    <a:p>
+                      <a:pPr algn="l"/>
+                      <a:r>
+                        <a:rPr sz="1350" b="0">
+                          <a:solidFill>
+                            <a:srgbClr val="141C1E"/>
+                          </a:solidFill>
+                          <a:latin typeface="Segoe UI"/>
+                        </a:rPr>
+                        <a:t>80.7</a:t>
+                      </a:r>
+                    </a:p>
+                  </a:txBody>
+                  <a:tcPr marL="128016" marR="128016" marT="45720" marB="45720" anchor="ctr">
+                    <a:solidFill>
+                      <a:srgbClr val="FFFFFF"/>
                     </a:solidFill>
                   </a:tcPr>
                 </a:tc>
@@ -19272,13 +19622,52 @@
       </p:graphicFrame>
       <p:sp>
         <p:nvSpPr>
-          <p:cNvPr id="8" name="Rectangle 7"/>
+          <p:cNvPr id="8" name="TextBox 7"/>
+          <p:cNvSpPr txBox="1"/>
+          <p:nvPr/>
+        </p:nvSpPr>
+        <p:spPr>
+          <a:xfrm>
+            <a:off x="777240" y="4590288"/>
+            <a:ext cx="10637215" cy="256032"/>
+          </a:xfrm>
+          <a:prstGeom prst="rect">
+            <a:avLst/>
+          </a:prstGeom>
+          <a:noFill/>
+        </p:spPr>
+        <p:txBody>
+          <a:bodyPr wrap="square" lIns="0" rIns="0" tIns="0" bIns="0">
+            <a:spAutoFit/>
+          </a:bodyPr>
+          <a:lstStyle/>
+          <a:p>
+            <a:pPr algn="l">
+              <a:lnSpc>
+                <a:spcPct val="100000"/>
+              </a:lnSpc>
+            </a:pPr>
+            <a:r>
+              <a:rPr sz="1100" b="0" i="1">
+                <a:solidFill>
+                  <a:srgbClr val="617274"/>
+                </a:solidFill>
+                <a:latin typeface="Segoe UI"/>
+              </a:rPr>
+              <a:t>‡ from LAVAD [3], Table 1. All other figures from AnyAnomaly [2], Tables 5–6.  Ours: Avenue/ShT one shared sentence; UCF one sentence per video.</a:t>
+            </a:r>
+          </a:p>
+        </p:txBody>
+      </p:sp>
+      <p:sp>
+        <p:nvSpPr>
+          <p:cNvPr id="9" name="Rectangle 8"/>
           <p:cNvSpPr/>
           <p:nvPr/>
         </p:nvSpPr>
         <p:spPr>
           <a:xfrm>
-            <a:off x="777240" y="4553712"/>
+            <a:off x="777240" y="5047488"/>
             <a:ext cx="68580" cy="68580"/>
           </a:xfrm>
           <a:prstGeom prst="rect">
@@ -19316,13 +19705,13 @@
       </p:sp>
       <p:sp>
         <p:nvSpPr>
-          <p:cNvPr id="9" name="TextBox 8"/>
+          <p:cNvPr id="10" name="TextBox 9"/>
           <p:cNvSpPr txBox="1"/>
           <p:nvPr/>
         </p:nvSpPr>
         <p:spPr>
           <a:xfrm>
-            <a:off x="1014983" y="4425696"/>
+            <a:off x="1014983" y="4919472"/>
             <a:ext cx="10399471" cy="365760"/>
           </a:xfrm>
           <a:prstGeom prst="rect">
@@ -19342,7 +19731,7 @@
               </a:lnSpc>
             </a:pPr>
             <a:r>
-              <a:rPr sz="1400" b="1">
+              <a:rPr sz="1350" b="1">
                 <a:solidFill>
                   <a:srgbClr val="141C1E"/>
                 </a:solidFill>
@@ -19351,27 +19740,71 @@
               <a:t>AnyAnomaly asks “is the thing I named happening?”  We ask “is anything happening that doesn’t belong here?”  </a:t>
             </a:r>
             <a:r>
-              <a:rPr sz="1400">
+              <a:rPr sz="1350">
                 <a:solidFill>
                   <a:srgbClr val="3A4A4C"/>
                 </a:solidFill>
                 <a:latin typeface="Segoe UI"/>
               </a:rPr>
-              <a:t>Theirs needs the operator to list what could go wrong. Ours needs a description of the ordinary. Their 79.7 is obtained by handing the model the benchmark’s own anomaly classes.</a:t>
-            </a:r>
-          </a:p>
-        </p:txBody>
-      </p:sp>
-      <p:sp>
-        <p:nvSpPr>
-          <p:cNvPr id="10" name="Rectangle 9"/>
+              <a:t>Theirs needs a list of what could go wrong — at evaluation it is handed the benchmark’s own anomaly classes. Ours needs a description of the ordinary.</a:t>
+            </a:r>
+          </a:p>
+        </p:txBody>
+      </p:sp>
+      <p:sp>
+        <p:nvSpPr>
+          <p:cNvPr id="11" name="Rectangle 10"/>
           <p:cNvSpPr/>
           <p:nvPr/>
         </p:nvSpPr>
         <p:spPr>
           <a:xfrm>
-            <a:off x="777240" y="5376672"/>
-            <a:ext cx="68580" cy="68580"/>
+            <a:off x="777240" y="5806440"/>
+            <a:ext cx="10637215" cy="777240"/>
+          </a:xfrm>
+          <a:prstGeom prst="rect">
+            <a:avLst/>
+          </a:prstGeom>
+          <a:solidFill>
+            <a:srgbClr val="DDEDEB"/>
+          </a:solidFill>
+          <a:ln>
+            <a:noFill/>
+          </a:ln>
+          <a:effectLst/>
+        </p:spPr>
+        <p:style>
+          <a:lnRef idx="1">
+            <a:schemeClr val="accent1"/>
+          </a:lnRef>
+          <a:fillRef idx="3">
+            <a:schemeClr val="accent1"/>
+          </a:fillRef>
+          <a:effectRef idx="2">
+            <a:schemeClr val="accent1"/>
+          </a:effectRef>
+          <a:fontRef idx="minor">
+            <a:schemeClr val="lt1"/>
+          </a:fontRef>
+        </p:style>
+        <p:txBody>
+          <a:bodyPr rtlCol="0" anchor="ctr"/>
+          <a:lstStyle/>
+          <a:p>
+            <a:pPr algn="ctr"/>
+          </a:p>
+        </p:txBody>
+      </p:sp>
+      <p:sp>
+        <p:nvSpPr>
+          <p:cNvPr id="12" name="Rectangle 11"/>
+          <p:cNvSpPr/>
+          <p:nvPr/>
+        </p:nvSpPr>
+        <p:spPr>
+          <a:xfrm>
+            <a:off x="777240" y="5806440"/>
+            <a:ext cx="45720" cy="777240"/>
           </a:xfrm>
           <a:prstGeom prst="rect">
             <a:avLst/>
@@ -19408,149 +19841,13 @@
       </p:sp>
       <p:sp>
         <p:nvSpPr>
-          <p:cNvPr id="11" name="TextBox 10"/>
+          <p:cNvPr id="13" name="TextBox 12"/>
           <p:cNvSpPr txBox="1"/>
           <p:nvPr/>
         </p:nvSpPr>
         <p:spPr>
           <a:xfrm>
-            <a:off x="1014983" y="5248656"/>
-            <a:ext cx="10399471" cy="365760"/>
-          </a:xfrm>
-          <a:prstGeom prst="rect">
-            <a:avLst/>
-          </a:prstGeom>
-          <a:noFill/>
-        </p:spPr>
-        <p:txBody>
-          <a:bodyPr wrap="square" lIns="0" rIns="0" tIns="0" bIns="0">
-            <a:spAutoFit/>
-          </a:bodyPr>
-          <a:lstStyle/>
-          <a:p>
-            <a:pPr>
-              <a:lnSpc>
-                <a:spcPct val="125000"/>
-              </a:lnSpc>
-            </a:pPr>
-            <a:r>
-              <a:rPr sz="1400" b="1">
-                <a:solidFill>
-                  <a:srgbClr val="141C1E"/>
-                </a:solidFill>
-                <a:latin typeface="Segoe UI"/>
-              </a:rPr>
-              <a:t>Most of our margin over the plain baselines is protocol, not language.  </a:t>
-            </a:r>
-            <a:r>
-              <a:rPr sz="1400">
-                <a:solidFill>
-                  <a:srgbClr val="3A4A4C"/>
-                </a:solidFill>
-                <a:latin typeface="Segoe UI"/>
-              </a:rPr>
-              <a:t>With no descriptor we already reach 0.707 against zero-shot CLIP’s 60.9. The sentence adds 2.7 — the evidence for it is the mismatched condition, not this table.</a:t>
-            </a:r>
-          </a:p>
-        </p:txBody>
-      </p:sp>
-      <p:sp>
-        <p:nvSpPr>
-          <p:cNvPr id="12" name="Rectangle 11"/>
-          <p:cNvSpPr/>
-          <p:nvPr/>
-        </p:nvSpPr>
-        <p:spPr>
-          <a:xfrm>
-            <a:off x="777240" y="5888736"/>
-            <a:ext cx="10637215" cy="749808"/>
-          </a:xfrm>
-          <a:prstGeom prst="rect">
-            <a:avLst/>
-          </a:prstGeom>
-          <a:solidFill>
-            <a:srgbClr val="DDEDEB"/>
-          </a:solidFill>
-          <a:ln>
-            <a:noFill/>
-          </a:ln>
-          <a:effectLst/>
-        </p:spPr>
-        <p:style>
-          <a:lnRef idx="1">
-            <a:schemeClr val="accent1"/>
-          </a:lnRef>
-          <a:fillRef idx="3">
-            <a:schemeClr val="accent1"/>
-          </a:fillRef>
-          <a:effectRef idx="2">
-            <a:schemeClr val="accent1"/>
-          </a:effectRef>
-          <a:fontRef idx="minor">
-            <a:schemeClr val="lt1"/>
-          </a:fontRef>
-        </p:style>
-        <p:txBody>
-          <a:bodyPr rtlCol="0" anchor="ctr"/>
-          <a:lstStyle/>
-          <a:p>
-            <a:pPr algn="ctr"/>
-          </a:p>
-        </p:txBody>
-      </p:sp>
-      <p:sp>
-        <p:nvSpPr>
-          <p:cNvPr id="13" name="Rectangle 12"/>
-          <p:cNvSpPr/>
-          <p:nvPr/>
-        </p:nvSpPr>
-        <p:spPr>
-          <a:xfrm>
-            <a:off x="777240" y="5888736"/>
-            <a:ext cx="45720" cy="749808"/>
-          </a:xfrm>
-          <a:prstGeom prst="rect">
-            <a:avLst/>
-          </a:prstGeom>
-          <a:solidFill>
-            <a:srgbClr val="0D6B67"/>
-          </a:solidFill>
-          <a:ln>
-            <a:noFill/>
-          </a:ln>
-          <a:effectLst/>
-        </p:spPr>
-        <p:style>
-          <a:lnRef idx="1">
-            <a:schemeClr val="accent1"/>
-          </a:lnRef>
-          <a:fillRef idx="3">
-            <a:schemeClr val="accent1"/>
-          </a:fillRef>
-          <a:effectRef idx="2">
-            <a:schemeClr val="accent1"/>
-          </a:effectRef>
-          <a:fontRef idx="minor">
-            <a:schemeClr val="lt1"/>
-          </a:fontRef>
-        </p:style>
-        <p:txBody>
-          <a:bodyPr rtlCol="0" anchor="ctr"/>
-          <a:lstStyle/>
-          <a:p>
-            <a:pPr algn="ctr"/>
-          </a:p>
-        </p:txBody>
-      </p:sp>
-      <p:sp>
-        <p:nvSpPr>
-          <p:cNvPr id="14" name="TextBox 13"/>
-          <p:cNvSpPr txBox="1"/>
-          <p:nvPr/>
-        </p:nvSpPr>
-        <p:spPr>
-          <a:xfrm>
-            <a:off x="1033271" y="6035040"/>
+            <a:off x="1033271" y="5952744"/>
             <a:ext cx="10134295" cy="219456"/>
           </a:xfrm>
           <a:prstGeom prst="rect">
@@ -19576,21 +19873,21 @@
                 </a:solidFill>
                 <a:latin typeface="Segoe UI"/>
               </a:rPr>
-              <a:t>WHAT WE SOLVE THAT THEY DO NOT</a:t>
-            </a:r>
-          </a:p>
-        </p:txBody>
-      </p:sp>
-      <p:sp>
-        <p:nvSpPr>
-          <p:cNvPr id="15" name="TextBox 14"/>
+              <a:t>WHERE WE LEAD</a:t>
+            </a:r>
+          </a:p>
+        </p:txBody>
+      </p:sp>
+      <p:sp>
+        <p:nvSpPr>
+          <p:cNvPr id="14" name="TextBox 13"/>
           <p:cNvSpPr txBox="1"/>
           <p:nvPr/>
         </p:nvSpPr>
         <p:spPr>
           <a:xfrm>
-            <a:off x="1033271" y="6327648"/>
-            <a:ext cx="10134295" cy="182879"/>
+            <a:off x="1033271" y="6245352"/>
+            <a:ext cx="10134295" cy="210311"/>
           </a:xfrm>
           <a:prstGeom prst="rect">
             <a:avLst/>
@@ -19609,13 +19906,13 @@
               </a:lnSpc>
             </a:pPr>
             <a:r>
-              <a:rPr sz="1400" b="0" i="0">
+              <a:rPr sz="1350" b="0" i="0">
                 <a:solidFill>
                   <a:srgbClr val="141C1E"/>
                 </a:solidFill>
                 <a:latin typeface="Segoe UI"/>
               </a:rPr>
-              <a:t>Anomalies nobody listed in advance — and 0.824 on UCF-Crime, where LAVAD reports 0.803.</a:t>
+              <a:t>First of six training-free methods on UCF-Crime; behind AnyAnomaly on the campus benchmarks.</a:t>
             </a:r>
           </a:p>
         </p:txBody>
@@ -20105,7 +20402,7 @@
                 </a:solidFill>
                 <a:latin typeface="Segoe UI"/>
               </a:rPr>
-              <a:t>The metric is scale-sensitive.  </a:t>
+              <a:t>What the sentence actually does is not settled.  </a:t>
             </a:r>
             <a:r>
               <a:rPr sz="1450">
@@ -20114,7 +20411,7 @@
                 </a:solidFill>
                 <a:latin typeface="Segoe UI"/>
               </a:rPr>
-              <a:t>Per-clip normalisation is affine, so a monotone rescaling of the score changes the pooled figure even though the ranking is identical. We found this the hard way.</a:t>
+              <a:t>Inside each video it barely re-ranks frames (+0.006); most of the 0.105 is per-video score shifts that the pooled metric rewards. An audit is the next experiment.</a:t>
             </a:r>
           </a:p>
         </p:txBody>
@@ -20197,7 +20494,7 @@
                 </a:solidFill>
                 <a:latin typeface="Segoe UI"/>
               </a:rPr>
-              <a:t>Configuration selection.  </a:t>
+              <a:t>The metrics are scale-sensitive.  </a:t>
             </a:r>
             <a:r>
               <a:rPr sz="1450">
@@ -20206,7 +20503,7 @@
                 </a:solidFill>
                 <a:latin typeface="Segoe UI"/>
               </a:rPr>
-              <a:t>No validation split exists for these benchmarks, so we split clips and report the half never used to select.</a:t>
+              <a:t>Softmax plus per-clip normalisation changes pooled figures without changing rankings; on UCF-Crime the effect shrinks under per-video normalisation.</a:t>
             </a:r>
           </a:p>
         </p:txBody>
@@ -20289,7 +20586,7 @@
                 </a:solidFill>
                 <a:latin typeface="Segoe UI"/>
               </a:rPr>
-              <a:t>Metric sensitivity on UCF-Crime.  </a:t>
+              <a:t>Configuration selection.  </a:t>
             </a:r>
             <a:r>
               <a:rPr sz="1450">
@@ -20298,7 +20595,7 @@
                 </a:solidFill>
                 <a:latin typeface="Segoe UI"/>
               </a:rPr>
-              <a:t>Under per-video normalisation the context effect shrinks sharply; we report the pre-registered raw metric.</a:t>
+              <a:t>No validation split exists for these benchmarks, so we split clips and report the half never used to select.</a:t>
             </a:r>
           </a:p>
         </p:txBody>
@@ -20749,7 +21046,7 @@
                           </a:solidFill>
                           <a:latin typeface="Segoe UI"/>
                         </a:rPr>
-                        <a:t>XD-Violence, same pre-registered protocol</a:t>
+                        <a:t>Measurement audit: within-video ranking and raw scores, all benchmarks</a:t>
                       </a:r>
                     </a:p>
                   </a:txBody>
@@ -20772,7 +21069,7 @@
                           </a:solidFill>
                           <a:latin typeface="Segoe UI"/>
                         </a:rPr>
-                        <a:t>LAVAD's second benchmark; metric is average precision</a:t>
+                        <a:t>Decides what the sentence really does: re-ranks frames or calibrates cameras</a:t>
                       </a:r>
                     </a:p>
                   </a:txBody>
@@ -20820,7 +21117,7 @@
                           </a:solidFill>
                           <a:latin typeface="Segoe UI"/>
                         </a:rPr>
-                        <a:t>Patch-level scoring against spatial tokens</a:t>
+                        <a:t>XD-Violence (pre-registered) and UCF-Crime on every frame</a:t>
                       </a:r>
                     </a:p>
                   </a:txBody>
@@ -20843,7 +21140,7 @@
                           </a:solidFill>
                           <a:latin typeface="Segoe UI"/>
                         </a:rPr>
-                        <a:t>Most likely route to a materially higher figure</a:t>
+                        <a:t>LAVAD's second benchmark; makes the comparison airtight</a:t>
                       </a:r>
                     </a:p>
                   </a:txBody>
@@ -20891,7 +21188,7 @@
                           </a:solidFill>
                           <a:latin typeface="Segoe UI"/>
                         </a:rPr>
-                        <a:t>M4 explanations under matched vs mismatched context</a:t>
+                        <a:t>NWPU Campus — scene-dependent anomalies</a:t>
                       </a:r>
                     </a:p>
                   </a:txBody>
@@ -20914,7 +21211,7 @@
                           </a:solidFill>
                           <a:latin typeface="Segoe UI"/>
                         </a:rPr>
-                        <a:t>Completes the framework; supplies the qualitative result</a:t>
+                        <a:t>The only benchmark where the same event flips label by scene: a direct concept-shift test</a:t>
                       </a:r>
                     </a:p>
                   </a:txBody>
@@ -20962,7 +21259,7 @@
                           </a:solidFill>
                           <a:latin typeface="Segoe UI"/>
                         </a:rPr>
-                        <a:t>UCF-Crime with scores propagated to every frame</a:t>
+                        <a:t>Patch-level scoring; M4 explanations</a:t>
                       </a:r>
                     </a:p>
                   </a:txBody>
@@ -20985,7 +21282,7 @@
                           </a:solidFill>
                           <a:latin typeface="Segoe UI"/>
                         </a:rPr>
-                        <a:t>Comparable to LAVAD under either reading of its protocol</a:t>
+                        <a:t>Higher figure on small anomalies; completes the framework for the thesis</a:t>
                       </a:r>
                     </a:p>
                   </a:txBody>
@@ -21161,7 +21458,7 @@
                 </a:solidFill>
                 <a:latin typeface="Segoe UI"/>
               </a:rPr>
-              <a:t>Within-view control with a confidence interval; prototype direction measured; per-camera sentences written by the system (0.751); UCF-Crime under pre-registered predictions (0.824).</a:t>
+              <a:t>Within-view control with a confidence interval; prototype direction measured; per-camera sentences written by the system (0.751); UCF-Crime under pre-registered predictions (0.824); every citation checked against its source.</a:t>
             </a:r>
           </a:p>
         </p:txBody>
@@ -22574,7 +22871,7 @@
                 </a:solidFill>
                 <a:latin typeface="Segoe UI"/>
               </a:rPr>
-              <a:t>0.751 on ShanghaiTech and 0.824 on UCF-Crime with no training; a wrong description costs 0.105 — the text is load-bearing.</a:t>
+              <a:t>0.751 on ShanghaiTech and 0.824 on UCF-Crime with no training. A wrong sentence costs 0.105 — mostly by shifting scores between videos.</a:t>
             </a:r>
           </a:p>
         </p:txBody>
@@ -23254,7 +23551,7 @@
                 </a:solidFill>
                 <a:latin typeface="Segoe UI"/>
               </a:rPr>
-              <a:t>A. Radford, J. W. Kim, C. Hallacy, A. Ramesh, G. Goh, S. Agarwal, G. Sastry, A. Askell, P. Mishkin, J. Clark, G. Krueger, I. Sutskever, Learning transferable visual models from natural language supervision, in: Proceedings of the International Conference on Machine Learning (ICML), 2021, pp. 8748–8763.</a:t>
+              <a:t>S. Ahn, Y. Jo, K. Lee, S. Kwon, I. Hong, S. Park, AnyAnomaly: Zero-shot customizable video anomaly detection with LVLM, in: Proceedings of the IEEE/CVF Winter Conference on Applications of Computer Vision (WACV), 2026, pp. 3026–3035.</a:t>
             </a:r>
           </a:p>
         </p:txBody>
@@ -23302,7 +23599,7 @@
                 </a:solidFill>
                 <a:latin typeface="Segoe UI"/>
               </a:rPr>
-              <a:t>J. Jeong, Y. Zou, T. Kim, D. Zhang, A. Ravichandran, O. Dabeer, WinCLIP: Zero-/few-shot anomaly classification and segmentation, in: Proceedings of the IEEE/CVF Conference on Computer Vision and Pattern Recognition (CVPR), 2023, pp. 19606–19616.</a:t>
+              <a:t>L. Zanella, W. Menapace, M. Mancini, Y. Wang, E. Ricci, Harnessing large language models for training-free video anomaly detection, in: Proceedings of the IEEE/CVF Conference on Computer Vision and Pattern Recognition (CVPR), 2024, pp. 18527–18536.</a:t>
             </a:r>
           </a:p>
         </p:txBody>
@@ -23350,7 +23647,7 @@
                 </a:solidFill>
                 <a:latin typeface="Segoe UI"/>
               </a:rPr>
-              <a:t>Q. Zhou, G. Pang, Y. Tian, S. He, J. Chen, AnomalyCLIP: Object-agnostic prompt learning for zero-shot anomaly detection, in: Proceedings of the International Conference on Learning Representations (ICLR), 2024.</a:t>
+              <a:t>A. Radford, J. W. Kim, C. Hallacy, A. Ramesh, G. Goh, S. Agarwal, G. Sastry, A. Askell, P. Mishkin, J. Clark, G. Krueger, I. Sutskever, Learning transferable visual models from natural language supervision, in: Proceedings of the International Conference on Machine Learning (ICML), 2021, pp. 8748–8763.</a:t>
             </a:r>
           </a:p>
         </p:txBody>
@@ -23398,7 +23695,7 @@
                 </a:solidFill>
                 <a:latin typeface="Segoe UI"/>
               </a:rPr>
-              <a:t>P. Bergmann, M. Fauser, D. Sattlegger, C. Steger, MVTec AD — A comprehensive real-world dataset for unsupervised anomaly detection, in: Proceedings of the IEEE/CVF Conference on Computer Vision and Pattern Recognition (CVPR), 2019, pp. 9592–9600.</a:t>
+              <a:t>J. Jeong, Y. Zou, T. Kim, D. Zhang, A. Ravichandran, O. Dabeer, WinCLIP: Zero-/few-shot anomaly classification and segmentation, in: Proceedings of the IEEE/CVF Conference on Computer Vision and Pattern Recognition (CVPR), 2023, pp. 19606–19616.</a:t>
             </a:r>
           </a:p>
         </p:txBody>
@@ -23446,7 +23743,7 @@
                 </a:solidFill>
                 <a:latin typeface="Segoe UI"/>
               </a:rPr>
-              <a:t>K. Roth, L. Pemula, J. Zepeda, B. Schölkopf, T. Brox, P. Gehler, Towards total recall in industrial anomaly detection, in: Proceedings of the IEEE/CVF Conference on Computer Vision and Pattern Recognition (CVPR), 2022, pp. 14318–14328.</a:t>
+              <a:t>Q. Zhou, G. Pang, Y. Tian, S. He, J. Chen, AnomalyCLIP: Object-agnostic prompt learning for zero-shot anomaly detection, in: Proceedings of the International Conference on Learning Representations (ICLR), 2024.</a:t>
             </a:r>
           </a:p>
         </p:txBody>
@@ -23494,7 +23791,7 @@
                 </a:solidFill>
                 <a:latin typeface="Segoe UI"/>
               </a:rPr>
-              <a:t>L. Zanella, W. Menapace, M. Mancini, Y. Wang, E. Ricci, Harnessing large language models for training-free video anomaly detection, in: Proceedings of the IEEE/CVF Conference on Computer Vision and Pattern Recognition (CVPR), 2024, pp. 18527–18536.</a:t>
+              <a:t>P. Bergmann, M. Fauser, D. Sattlegger, C. Steger, MVTec AD — A comprehensive real-world dataset for unsupervised anomaly detection, in: Proceedings of the IEEE/CVF Conference on Computer Vision and Pattern Recognition (CVPR), 2019, pp. 9592–9600.</a:t>
             </a:r>
           </a:p>
         </p:txBody>
@@ -23542,7 +23839,7 @@
                 </a:solidFill>
                 <a:latin typeface="Segoe UI"/>
               </a:rPr>
-              <a:t>M. Ye, W. Liu, P. He, VERA: Explainable video anomaly detection via verbalized learning of vision-language models, in: Proceedings of the IEEE/CVF Conference on Computer Vision and Pattern Recognition (CVPR), 2025. ArXiv:2412.01095.</a:t>
+              <a:t>K. Roth, L. Pemula, J. Zepeda, B. Schölkopf, T. Brox, P. Gehler, Towards total recall in industrial anomaly detection, in: Proceedings of the IEEE/CVF Conference on Computer Vision and Pattern Recognition (CVPR), 2022, pp. 14318–14328.</a:t>
             </a:r>
           </a:p>
         </p:txBody>
@@ -23590,7 +23887,7 @@
                 </a:solidFill>
                 <a:latin typeface="Segoe UI"/>
               </a:rPr>
-              <a:t>S. Ahn, Y. Jo, K. Lee, S. Kwon, I. Hong, S. Park, AnyAnomaly: Zero-shot customizable video anomaly detection with LVLM, in: Proceedings of the IEEE/CVF Winter Conference on Applications of Computer Vision (WACV), 2026, pp. 3026–3035.</a:t>
+              <a:t>M. Ye, W. Liu, P. He, VERA: Explainable video anomaly detection via verbalized learning of vision-language models, in: Proceedings of the IEEE/CVF Conference on Computer Vision and Pattern Recognition (CVPR), 2025, pp. 8679–8688.</a:t>
             </a:r>
           </a:p>
         </p:txBody>
@@ -26259,7 +26556,7 @@
                 </a:solidFill>
                 <a:latin typeface="Segoe UI"/>
               </a:rPr>
-              <a:t>DA-ZVAD: adapt by writing a sentence</a:t>
+              <a:t>DA-ZVAD: one sentence per camera, written by the system</a:t>
             </a:r>
           </a:p>
         </p:txBody>
@@ -26497,7 +26794,7 @@
                 </a:solidFill>
                 <a:latin typeface="Segoe UI"/>
               </a:rPr>
-              <a:t>Frozen CLIP [2] scores each frame: normal vs abnormal text.</a:t>
+              <a:t>Frozen CLIP [4] scores each frame: normal vs abnormal text.</a:t>
             </a:r>
           </a:p>
         </p:txBody>
@@ -27604,7 +27901,7 @@
                 </a:solidFill>
                 <a:latin typeface="Segoe UI"/>
               </a:rPr>
-              <a:t>This is what makes the adaptation claim testable rather than asserted. You cannot run our central experiment on the competing systems — their text is learned on source data [4], or entangled in an LLM prior [7], or accompanied by a trained adapter [17].</a:t>
+              <a:t>This is what makes the adaptation claim testable rather than asserted. You cannot run our central experiment on the competing systems — their text is learned on training data [9], or entangled in an LLM prior [3], or paired with trained detection heads [10].</a:t>
             </a:r>
           </a:p>
         </p:txBody>
@@ -28690,8 +28987,8 @@
           <p:nvPr/>
         </p:nvGraphicFramePr>
         <p:xfrm>
-          <a:off x="777240" y="1828800"/>
-          <a:ext cx="10634472" cy="2377440"/>
+          <a:off x="777240" y="1783080"/>
+          <a:ext cx="10634472" cy="2743200"/>
         </p:xfrm>
         <a:graphic>
           <a:graphicData uri="http://schemas.openxmlformats.org/drawingml/2006/table">
@@ -28700,10 +28997,10 @@
                 <a:tableStyleId>{5C22544A-7EE6-4342-B048-85BDC9FD1C3A}</a:tableStyleId>
               </a:tblPr>
               <a:tblGrid>
-                <a:gridCol w="2194560"/>
-                <a:gridCol w="8439912"/>
+                <a:gridCol w="1463040"/>
+                <a:gridCol w="9171432"/>
               </a:tblGrid>
-              <a:tr h="475488">
+              <a:tr h="457200">
                 <a:tc>
                   <a:txBody>
                     <a:bodyPr wrap="square"/>
@@ -28711,13 +29008,13 @@
                     <a:p>
                       <a:pPr algn="l"/>
                       <a:r>
-                        <a:rPr sz="1500" b="0">
+                        <a:rPr sz="1400" b="0">
                           <a:solidFill>
                             <a:srgbClr val="141C1E"/>
                           </a:solidFill>
                           <a:latin typeface="Segoe UI"/>
                         </a:rPr>
-                        <a:t>Benchmarks</a:t>
+                        <a:t>Video</a:t>
                       </a:r>
                     </a:p>
                   </a:txBody>
@@ -28734,13 +29031,13 @@
                     <a:p>
                       <a:pPr algn="l"/>
                       <a:r>
-                        <a:rPr sz="1500" b="0">
+                        <a:rPr sz="1400" b="0">
                           <a:solidFill>
                             <a:srgbClr val="141C1E"/>
                           </a:solidFill>
                           <a:latin typeface="Segoe UI"/>
                         </a:rPr>
-                        <a:t>ShanghaiTech [21] (12 views) and CUHK Avenue [26] (1 view)</a:t>
+                        <a:t>ShanghaiTech [21] (12 views) · CUHK Avenue [26] (1 view) · UCF-Crime [27] (~290 scenes)</a:t>
                       </a:r>
                     </a:p>
                   </a:txBody>
@@ -28751,7 +29048,7 @@
                   </a:tcPr>
                 </a:tc>
               </a:tr>
-              <a:tr h="475488">
+              <a:tr h="457200">
                 <a:tc>
                   <a:txBody>
                     <a:bodyPr wrap="square"/>
@@ -28759,13 +29056,13 @@
                     <a:p>
                       <a:pPr algn="l"/>
                       <a:r>
-                        <a:rPr sz="1500" b="0">
+                        <a:rPr sz="1400" b="0">
                           <a:solidFill>
                             <a:srgbClr val="141C1E"/>
                           </a:solidFill>
                           <a:latin typeface="Segoe UI"/>
                         </a:rPr>
-                        <a:t>Scale</a:t>
+                        <a:t>Image</a:t>
                       </a:r>
                     </a:p>
                   </a:txBody>
@@ -28782,13 +29079,13 @@
                     <a:p>
                       <a:pPr algn="l"/>
                       <a:r>
-                        <a:rPr sz="1500" b="0">
+                        <a:rPr sz="1400" b="0">
                           <a:solidFill>
                             <a:srgbClr val="141C1E"/>
                           </a:solidFill>
                           <a:latin typeface="Segoe UI"/>
                         </a:rPr>
-                        <a:t>128 test clips · 28,118 frames · frame-level ground truth</a:t>
+                        <a:t>MVTec AD [7] — detection baseline only</a:t>
                       </a:r>
                     </a:p>
                   </a:txBody>
@@ -28799,7 +29096,7 @@
                   </a:tcPr>
                 </a:tc>
               </a:tr>
-              <a:tr h="475488">
+              <a:tr h="457200">
                 <a:tc>
                   <a:txBody>
                     <a:bodyPr wrap="square"/>
@@ -28807,7 +29104,103 @@
                     <a:p>
                       <a:pPr algn="l"/>
                       <a:r>
-                        <a:rPr sz="1500" b="0">
+                        <a:rPr sz="1400" b="0">
+                          <a:solidFill>
+                            <a:srgbClr val="141C1E"/>
+                          </a:solidFill>
+                          <a:latin typeface="Segoe UI"/>
+                        </a:rPr>
+                        <a:t>Scale</a:t>
+                      </a:r>
+                    </a:p>
+                  </a:txBody>
+                  <a:tcPr marL="128016" marR="128016" marT="45720" marB="45720" anchor="ctr">
+                    <a:solidFill>
+                      <a:srgbClr val="F5F7F7"/>
+                    </a:solidFill>
+                  </a:tcPr>
+                </a:tc>
+                <a:tc>
+                  <a:txBody>
+                    <a:bodyPr wrap="square"/>
+                    <a:lstStyle/>
+                    <a:p>
+                      <a:pPr algn="l"/>
+                      <a:r>
+                        <a:rPr sz="1400" b="0">
+                          <a:solidFill>
+                            <a:srgbClr val="141C1E"/>
+                          </a:solidFill>
+                          <a:latin typeface="Segoe UI"/>
+                        </a:rPr>
+                        <a:t>418 test videos · 97,752 sampled frames · frame-level ground truth</a:t>
+                      </a:r>
+                    </a:p>
+                  </a:txBody>
+                  <a:tcPr marL="128016" marR="128016" marT="45720" marB="45720" anchor="ctr">
+                    <a:solidFill>
+                      <a:srgbClr val="F5F7F7"/>
+                    </a:solidFill>
+                  </a:tcPr>
+                </a:tc>
+              </a:tr>
+              <a:tr h="457200">
+                <a:tc>
+                  <a:txBody>
+                    <a:bodyPr wrap="square"/>
+                    <a:lstStyle/>
+                    <a:p>
+                      <a:pPr algn="l"/>
+                      <a:r>
+                        <a:rPr sz="1400" b="0">
+                          <a:solidFill>
+                            <a:srgbClr val="141C1E"/>
+                          </a:solidFill>
+                          <a:latin typeface="Segoe UI"/>
+                        </a:rPr>
+                        <a:t>Models</a:t>
+                      </a:r>
+                    </a:p>
+                  </a:txBody>
+                  <a:tcPr marL="128016" marR="128016" marT="45720" marB="45720" anchor="ctr">
+                    <a:solidFill>
+                      <a:srgbClr val="FFFFFF"/>
+                    </a:solidFill>
+                  </a:tcPr>
+                </a:tc>
+                <a:tc>
+                  <a:txBody>
+                    <a:bodyPr wrap="square"/>
+                    <a:lstStyle/>
+                    <a:p>
+                      <a:pPr algn="l"/>
+                      <a:r>
+                        <a:rPr sz="1400" b="0">
+                          <a:solidFill>
+                            <a:srgbClr val="141C1E"/>
+                          </a:solidFill>
+                          <a:latin typeface="Segoe UI"/>
+                        </a:rPr>
+                        <a:t>CLIP ViT-L/14 [4, 22] (LAION-2B) and LLaVA-1.5-7B [24] 4-bit — all frozen</a:t>
+                      </a:r>
+                    </a:p>
+                  </a:txBody>
+                  <a:tcPr marL="128016" marR="128016" marT="45720" marB="45720" anchor="ctr">
+                    <a:solidFill>
+                      <a:srgbClr val="FFFFFF"/>
+                    </a:solidFill>
+                  </a:tcPr>
+                </a:tc>
+              </a:tr>
+              <a:tr h="457200">
+                <a:tc>
+                  <a:txBody>
+                    <a:bodyPr wrap="square"/>
+                    <a:lstStyle/>
+                    <a:p>
+                      <a:pPr algn="l"/>
+                      <a:r>
+                        <a:rPr sz="1400" b="0">
                           <a:solidFill>
                             <a:srgbClr val="141C1E"/>
                           </a:solidFill>
@@ -28830,13 +29223,13 @@
                     <a:p>
                       <a:pPr algn="l"/>
                       <a:r>
-                        <a:rPr sz="1500" b="0">
+                        <a:rPr sz="1400" b="0">
                           <a:solidFill>
                             <a:srgbClr val="141C1E"/>
                           </a:solidFill>
                           <a:latin typeface="Segoe UI"/>
                         </a:rPr>
-                        <a:t>NVIDIA A40, college GPU server</a:t>
+                        <a:t>NVIDIA A40, college GPU server · PyTorch 2.3.1 / CUDA 12.1</a:t>
                       </a:r>
                     </a:p>
                   </a:txBody>
@@ -28847,7 +29240,7 @@
                   </a:tcPr>
                 </a:tc>
               </a:tr>
-              <a:tr h="475488">
+              <a:tr h="457200">
                 <a:tc>
                   <a:txBody>
                     <a:bodyPr wrap="square"/>
@@ -28855,13 +29248,13 @@
                     <a:p>
                       <a:pPr algn="l"/>
                       <a:r>
-                        <a:rPr sz="1500" b="0">
+                        <a:rPr sz="1400" b="0">
                           <a:solidFill>
                             <a:srgbClr val="141C1E"/>
                           </a:solidFill>
                           <a:latin typeface="Segoe UI"/>
                         </a:rPr>
-                        <a:t>Backbone</a:t>
+                        <a:t>Runs</a:t>
                       </a:r>
                     </a:p>
                   </a:txBody>
@@ -28878,13 +29271,13 @@
                     <a:p>
                       <a:pPr algn="l"/>
                       <a:r>
-                        <a:rPr sz="1500" b="0">
+                        <a:rPr sz="1400" b="0">
                           <a:solidFill>
                             <a:srgbClr val="141C1E"/>
                           </a:solidFill>
                           <a:latin typeface="Segoe UI"/>
                         </a:rPr>
-                        <a:t>CLIP ViT-L/14 [2, 22] (LAION-2B), frozen · PyTorch 2.3.1 / CUDA 12.1</a:t>
+                        <a:t>5 full runs, cached-embedding analyses, LLaVA captioning, UCF-Crime pre-registered run</a:t>
                       </a:r>
                     </a:p>
                   </a:txBody>
@@ -28895,54 +29288,6 @@
                   </a:tcPr>
                 </a:tc>
               </a:tr>
-              <a:tr h="475488">
-                <a:tc>
-                  <a:txBody>
-                    <a:bodyPr wrap="square"/>
-                    <a:lstStyle/>
-                    <a:p>
-                      <a:pPr algn="l"/>
-                      <a:r>
-                        <a:rPr sz="1500" b="0">
-                          <a:solidFill>
-                            <a:srgbClr val="141C1E"/>
-                          </a:solidFill>
-                          <a:latin typeface="Segoe UI"/>
-                        </a:rPr>
-                        <a:t>Runs</a:t>
-                      </a:r>
-                    </a:p>
-                  </a:txBody>
-                  <a:tcPr marL="128016" marR="128016" marT="45720" marB="45720" anchor="ctr">
-                    <a:solidFill>
-                      <a:srgbClr val="F5F7F7"/>
-                    </a:solidFill>
-                  </a:tcPr>
-                </a:tc>
-                <a:tc>
-                  <a:txBody>
-                    <a:bodyPr wrap="square"/>
-                    <a:lstStyle/>
-                    <a:p>
-                      <a:pPr algn="l"/>
-                      <a:r>
-                        <a:rPr sz="1500" b="0">
-                          <a:solidFill>
-                            <a:srgbClr val="141C1E"/>
-                          </a:solidFill>
-                          <a:latin typeface="Segoe UI"/>
-                        </a:rPr>
-                        <a:t>5 full experiment runs + cached-embedding analysis</a:t>
-                      </a:r>
-                    </a:p>
-                  </a:txBody>
-                  <a:tcPr marL="128016" marR="128016" marT="45720" marB="45720" anchor="ctr">
-                    <a:solidFill>
-                      <a:srgbClr val="F5F7F7"/>
-                    </a:solidFill>
-                  </a:tcPr>
-                </a:tc>
-              </a:tr>
             </a:tbl>
           </a:graphicData>
         </a:graphic>
@@ -28955,8 +29300,8 @@
         </p:nvSpPr>
         <p:spPr>
           <a:xfrm>
-            <a:off x="777240" y="4389120"/>
-            <a:ext cx="10637215" cy="1600200"/>
+            <a:off x="777240" y="4800600"/>
+            <a:ext cx="10637215" cy="1463040"/>
           </a:xfrm>
           <a:prstGeom prst="rect">
             <a:avLst/>
@@ -28999,8 +29344,8 @@
         </p:nvSpPr>
         <p:spPr>
           <a:xfrm>
-            <a:off x="777240" y="4389120"/>
-            <a:ext cx="45720" cy="1600200"/>
+            <a:off x="777240" y="4800600"/>
+            <a:ext cx="45720" cy="1463040"/>
           </a:xfrm>
           <a:prstGeom prst="rect">
             <a:avLst/>
@@ -29043,7 +29388,7 @@
         </p:nvSpPr>
         <p:spPr>
           <a:xfrm>
-            <a:off x="1033271" y="4535424"/>
+            <a:off x="1033271" y="4946904"/>
             <a:ext cx="10134295" cy="219456"/>
           </a:xfrm>
           <a:prstGeom prst="rect">
@@ -29082,8 +29427,8 @@
         </p:nvSpPr>
         <p:spPr>
           <a:xfrm>
-            <a:off x="1033271" y="4828031"/>
-            <a:ext cx="10134295" cy="1033271"/>
+            <a:off x="1033271" y="5239512"/>
+            <a:ext cx="10134295" cy="896112"/>
           </a:xfrm>
           <a:prstGeom prst="rect">
             <a:avLst/>
@@ -29102,7 +29447,7 @@
               </a:lnSpc>
             </a:pPr>
             <a:r>
-              <a:rPr sz="1500" b="0" i="0">
+              <a:rPr sz="1400" b="0" i="0">
                 <a:solidFill>
                   <a:srgbClr val="141C1E"/>
                 </a:solidFill>
@@ -29248,7 +29593,7 @@
                 </a:solidFill>
                 <a:latin typeface="Segoe UI"/>
               </a:rPr>
-              <a:t>What the two benchmarks actually look like</a:t>
+              <a:t>What the two campus benchmarks look like</a:t>
             </a:r>
           </a:p>
         </p:txBody>
@@ -29521,7 +29866,7 @@
                 </a:solidFill>
                 <a:latin typeface="Segoe UI"/>
               </a:rPr>
-              <a:t>Each column is one fixed camera, so the scene, the angle and the lighting are constant down a column and only the event changes. That is the whole argument in a photograph: an empty walkway and the same walkway with a cyclist look alike and are labelled opposite.</a:t>
+              <a:t>Each column is one fixed camera: the scene stays constant and only the event changes — an empty walkway and the same walkway with a cyclist look alike and are labelled opposite. UCF-Crime, added in Phase 3, is the opposite case: almost every one of its 290 videos is a different place.</a:t>
             </a:r>
           </a:p>
         </p:txBody>

</xml_diff>